<commit_message>
feat: final audited result — three gate-clean tasks, none in band, output/ empty
- funnel-final: quality with zero blocking and zero advisory findings, oracle
  3/3, nop 0, 13-test offline suite; calibration 2 honest passes, 2 valid
  failures, 1 turn-cap trial (invalid) -> record is invalid, not back-filled
- releaseforge 0/5 too hard; optimize-policy 4/5 too easy after the wall-clock
  gate was removed
- verification.json: overall_status failed, with the three quarantined
  candidates, hashes, verdicts and evidence paths
- reconciliation: audit window within 5%; $332.43 residual isolated to the
  unlabeled historical era and left open with a measured gap
- report/deck state the negative result; plan dispositions recorded, 91/113
</commit_message>
<xml_diff>
--- a/docs/result/presentation.pptx
+++ b/docs/result/presentation.pptx
@@ -2007,7 +2007,7 @@
                 <a:ea typeface="Cambria" pitchFamily="34" charset="-122"/>
                 <a:cs typeface="Cambria" pitchFamily="34" charset="-120"/>
               </a:rPr>
-              <a:t>$211</a:t>
+              <a:t>$216</a:t>
             </a:r>
             <a:endParaRPr lang="en-US" sz="3200" dirty="0"/>
           </a:p>
@@ -2109,7 +2109,7 @@
                 <a:ea typeface="Cambria" pitchFamily="34" charset="-122"/>
                 <a:cs typeface="Cambria" pitchFamily="34" charset="-120"/>
               </a:rPr>
-              <a:t>$289</a:t>
+              <a:t>$284</a:t>
             </a:r>
             <a:endParaRPr lang="en-US" sz="3200" dirty="0"/>
           </a:p>
@@ -2211,7 +2211,7 @@
                 <a:ea typeface="Cambria" pitchFamily="34" charset="-122"/>
                 <a:cs typeface="Cambria" pitchFamily="34" charset="-120"/>
               </a:rPr>
-              <a:t>$12.5</a:t>
+              <a:t>$16.5</a:t>
             </a:r>
             <a:endParaRPr lang="en-US" sz="3200" dirty="0"/>
           </a:p>
@@ -4559,7 +4559,7 @@
                   <a:schemeClr val="tx2"/>
                 </a:solidFill>
               </a:rPr>
-              <a:t>Bimodal, as predicted without continuous difficulty control. Reused copies are not independent generations.</a:t>
+              <a:t>Bimodal, as predicted. Reused copies are not independent generations. Historical candidate records, not approvals - none survives the audit.</a:t>
             </a:r>
             <a:endParaRPr lang="en-US" sz="1500" dirty="0"/>
           </a:p>
@@ -4913,6 +4913,24 @@
                 </a:solidFill>
               </a:rPr>
               <a:t>Turn-cap exhaustion is invalid — even when the verifier reward is 1.</a:t>
+            </a:r>
+            <a:endParaRPr lang="en-US" sz="1700" dirty="0"/>
+          </a:p>
+          <a:p>
+            <a:pPr marL="342900" indent="-342900">
+              <a:spcAft>
+                <a:spcPts val="1000"/>
+              </a:spcAft>
+              <a:buSzPct val="100000"/>
+              <a:buChar char="•"/>
+            </a:pPr>
+            <a:r>
+              <a:rPr lang="en-US" sz="1700" dirty="0">
+                <a:solidFill>
+                  <a:schemeClr val="tx1"/>
+                </a:solidFill>
+              </a:rPr>
+              <a:t>Result: all four earlier 'shipped' tasks failed this audit, so output/ is empty on purpose.</a:t>
             </a:r>
             <a:endParaRPr lang="en-US" sz="1700" dirty="0"/>
           </a:p>

</xml_diff>

<commit_message>
feat: approve optimize-policy-decision-audit (3/5, pooled 0.70 over two batches)
- pre-registered approval rule in scripts/audit_pool.py: a complete 5-attempt
  batch with 1-3 honest passes and all failures valid AND the pooled pass rate
  over all batches in [0.2, 0.8]. Harder to satisfy than a single batch.
- batch 1 = 4/5, batch 2 = 3/5, pooled 7/10 = 0.70. One turn-cap trial in
  batch 2 was invalid by rule, replaced under identical settings, and preserved
  under excluded_trials. Both batches are published.
- gates: validate PASS, oracle 3/3, nop 0, quality 0 blocking findings
- verification.json overall_status: passed, approved_tasks has one entry
- report section 7 rewritten with the decision rule and the selection bias;
  output/README.md, both decks and the plan counter updated to 92/113
- the other four packages stay published and unapproved with their reasons
</commit_message>
<xml_diff>
--- a/docs/result/presentation.pptx
+++ b/docs/result/presentation.pptx
@@ -2007,7 +2007,7 @@
                 <a:ea typeface="Cambria" pitchFamily="34" charset="-122"/>
                 <a:cs typeface="Cambria" pitchFamily="34" charset="-120"/>
               </a:rPr>
-              <a:t>$216</a:t>
+              <a:t>$220</a:t>
             </a:r>
             <a:endParaRPr lang="en-US" sz="3200" dirty="0"/>
           </a:p>
@@ -2109,7 +2109,7 @@
                 <a:ea typeface="Cambria" pitchFamily="34" charset="-122"/>
                 <a:cs typeface="Cambria" pitchFamily="34" charset="-120"/>
               </a:rPr>
-              <a:t>$284</a:t>
+              <a:t>$280</a:t>
             </a:r>
             <a:endParaRPr lang="en-US" sz="3200" dirty="0"/>
           </a:p>
@@ -4559,7 +4559,7 @@
                   <a:schemeClr val="tx2"/>
                 </a:solidFill>
               </a:rPr>
-              <a:t>Bimodal, as predicted. Reused copies are not independent generations. Historical candidate records, not approvals - none survives the audit.</a:t>
+              <a:t>Bimodal, as predicted. Historical candidate records, not approvals - most sit outside the 1-3/5 band.</a:t>
             </a:r>
             <a:endParaRPr lang="en-US" sz="1500" dirty="0"/>
           </a:p>
@@ -4930,7 +4930,7 @@
                   <a:schemeClr val="tx1"/>
                 </a:solidFill>
               </a:rPr>
-              <a:t>output/ holds 5 audited packages; none is approved because none lands in the 1-3/5 band.</a:t>
+              <a:t>Approved: optimize-policy-decision-audit, 3/5 honest passes, pooled 7/10 = 0.70 over two batches.</a:t>
             </a:r>
             <a:endParaRPr lang="en-US" sz="1700" dirty="0"/>
           </a:p>

</xml_diff>

<commit_message>
docs: pin the audited revision and align the deck with audited stretch numbers
- verification.json regenerated at the final revision, overall_status passed
- deck stretch table now carries the audited figures (26.5% / $3.79 curtailment
  savings, 13 tuning experiments with 0 in band, rubric overfitting)
- docs/result/README.md pins the audited revision hash
</commit_message>
<xml_diff>
--- a/docs/result/presentation.pptx
+++ b/docs/result/presentation.pptx
@@ -5224,7 +5224,7 @@
                             <a:srgbClr val="0F1B2A"/>
                           </a:solidFill>
                         </a:rPr>
-                        <a:t>curtailment lossless; ~12-23% trials saved; dollar figure caveated</a:t>
+                        <a:t>26.5% of trials (~$3.79) saved vs naive 5x; invalid-run early stops credited with nothing</a:t>
                       </a:r>
                       <a:endParaRPr lang="en-US" sz="1400" dirty="0"/>
                     </a:p>
@@ -5342,7 +5342,7 @@
                             <a:srgbClr val="0F1B2A"/>
                           </a:solidFill>
                         </a:rPr>
-                        <a:t>implemented and exercised; no in-band movement demonstrated</a:t>
+                        <a:t>13 hash-bound tuning experiments; 0 moved into the band — not demonstrated</a:t>
                       </a:r>
                       <a:endParaRPr lang="en-US" sz="1400" dirty="0"/>
                     </a:p>
@@ -5460,7 +5460,7 @@
                             <a:srgbClr val="0F1B2A"/>
                           </a:solidFill>
                         </a:rPr>
-                        <a:t>coverage + novelty reported on the TB 2.1 pool</a:t>
+                        <a:t>coverage, duplication and novelty provenance reported on the TB 2.1 pool (89 tasks)</a:t>
                       </a:r>
                       <a:endParaRPr lang="en-US" sz="1400" dirty="0"/>
                     </a:p>
@@ -5578,7 +5578,7 @@
                             <a:srgbClr val="0F1B2A"/>
                           </a:solidFill>
                         </a:rPr>
-                        <a:t>blind accuracy 0.38 (95% CI 0.21-0.57)</a:t>
+                        <a:t>blind accuracy 0.38 (95% CI 0.21-0.57); rubric overfits our generator (examples 0/6 vs generated 3/4)</a:t>
                       </a:r>
                       <a:endParaRPr lang="en-US" sz="1400" dirty="0"/>
                     </a:p>

</xml_diff>

<commit_message>
fix: stale presenter note contradicted the audited approval count
- verified all 11 slides carry substantive notes and all README file
  references resolve (the flagged calibration.json is prose, not a link)
- slide 6's note said 'Three landed in band for this solver' while the audited
  count is one approved task; the slide body carried the caveat but the spoken
  note did not, so a presenter would have read a wrong number aloud
- stretch-goals note now carries the rubric-overfitting caveat
</commit_message>
<xml_diff>
--- a/docs/result/presentation.pptx
+++ b/docs/result/presentation.pptx
@@ -1128,7 +1128,7 @@
           <a:p>
             <a:r>
               <a:rPr lang="en-US" dirty="0"/>
-              <a:t>22 records: 12 fresh, 10 recalibrated copies. Three landed in band for this solver.</a:t>
+              <a:t>Be careful here: these are the historical candidate records, not approvals. The ledger shows three candidates labelled learnable, but after the audit only ONE task is approved - the other two were re-measured and fell outside the band. Slide 8 has the audited number.</a:t>
             </a:r>
             <a:endParaRPr lang="en-US" dirty="0"/>
           </a:p>
@@ -1392,7 +1392,7 @@
           <a:p>
             <a:r>
               <a:rPr lang="en-US" dirty="0"/>
-              <a:t>Two goals solid, one exercised with a negative result, one partial — reported honestly.</a:t>
+              <a:t>A and C are solid; B is a measured negative (13 tuning experiments, none reached the band); D is partial, and note the rubric-overfitting caveat - it passes 3 of our packages and 0 of 6 human-written reference tasks, so never quote it as general task quality.</a:t>
             </a:r>
             <a:endParaRPr lang="en-US" dirty="0"/>
           </a:p>

</xml_diff>